<commit_message>
Expand openMap explanation in presentation
Co-authored-by: heeyoung <heeyoung5454@users.noreply.github.com>
</commit_message>
<xml_diff>
--- a/react-filter-project-presentation.pptx
+++ b/react-filter-project-presentation.pptx
@@ -12507,6 +12507,631 @@
           </a:p>
         </p:txBody>
       </p:sp>
+      <p:sp>
+        <p:nvSpPr>
+          <p:cNvPr id="27" name="Rounded Rectangle 26"/>
+          <p:cNvSpPr/>
+          <p:nvPr/>
+        </p:nvSpPr>
+        <p:spPr>
+          <a:xfrm>
+            <a:off x="868680" y="3063240"/>
+            <a:ext cx="10424160" cy="603504"/>
+          </a:xfrm>
+          <a:prstGeom prst="roundRect">
+            <a:avLst/>
+          </a:prstGeom>
+          <a:solidFill>
+            <a:srgbClr val="FFFFFF"/>
+          </a:solidFill>
+          <a:ln>
+            <a:solidFill>
+              <a:srgbClr val="CBD5E1"/>
+            </a:solidFill>
+          </a:ln>
+        </p:spPr>
+        <p:style>
+          <a:lnRef idx="1">
+            <a:schemeClr val="accent1"/>
+          </a:lnRef>
+          <a:fillRef idx="3">
+            <a:schemeClr val="accent1"/>
+          </a:fillRef>
+          <a:effectRef idx="2">
+            <a:schemeClr val="accent1"/>
+          </a:effectRef>
+          <a:fontRef idx="minor">
+            <a:schemeClr val="lt1"/>
+          </a:fontRef>
+        </p:style>
+        <p:txBody>
+          <a:bodyPr rtlCol="0" anchor="ctr" wrap="square">
+            <a:normAutofit/>
+          </a:bodyPr>
+          <a:lstStyle/>
+          <a:p>
+            <a:pPr algn="ctr"/>
+            <a:r>
+              <a:rPr sz="1000" b="1">
+                <a:solidFill>
+                  <a:srgbClr val="0F172A"/>
+                </a:solidFill>
+                <a:latin typeface="Noto Sans CJK KR"/>
+              </a:rPr>
+              <a:t>openMap 동작: 경로 key를 기준으로 “열려 있는 노드”만 true로 저장하고, 렌더링에서 open 여부를 판단</a:t>
+            </a:r>
+          </a:p>
+        </p:txBody>
+      </p:sp>
+      <p:sp>
+        <p:nvSpPr>
+          <p:cNvPr id="28" name="Rounded Rectangle 27"/>
+          <p:cNvSpPr/>
+          <p:nvPr/>
+        </p:nvSpPr>
+        <p:spPr>
+          <a:xfrm>
+            <a:off x="1051560" y="5074920"/>
+            <a:ext cx="1920240" cy="621792"/>
+          </a:xfrm>
+          <a:prstGeom prst="roundRect">
+            <a:avLst/>
+          </a:prstGeom>
+          <a:solidFill>
+            <a:srgbClr val="DBEAFE"/>
+          </a:solidFill>
+          <a:ln w="13335">
+            <a:solidFill>
+              <a:srgbClr val="2563EB"/>
+            </a:solidFill>
+          </a:ln>
+        </p:spPr>
+        <p:style>
+          <a:lnRef idx="1">
+            <a:schemeClr val="accent1"/>
+          </a:lnRef>
+          <a:fillRef idx="3">
+            <a:schemeClr val="accent1"/>
+          </a:fillRef>
+          <a:effectRef idx="2">
+            <a:schemeClr val="accent1"/>
+          </a:effectRef>
+          <a:fontRef idx="minor">
+            <a:schemeClr val="lt1"/>
+          </a:fontRef>
+        </p:style>
+        <p:txBody>
+          <a:bodyPr rtlCol="0" anchor="ctr"/>
+          <a:lstStyle/>
+          <a:p>
+            <a:pPr algn="ctr"/>
+          </a:p>
+        </p:txBody>
+      </p:sp>
+      <p:sp>
+        <p:nvSpPr>
+          <p:cNvPr id="29" name="TextBox 28"/>
+          <p:cNvSpPr txBox="1"/>
+          <p:nvPr/>
+        </p:nvSpPr>
+        <p:spPr>
+          <a:xfrm>
+            <a:off x="1124712" y="5138928"/>
+            <a:ext cx="1773936" cy="237744"/>
+          </a:xfrm>
+          <a:prstGeom prst="rect">
+            <a:avLst/>
+          </a:prstGeom>
+          <a:noFill/>
+        </p:spPr>
+        <p:txBody>
+          <a:bodyPr wrap="square">
+            <a:normAutofit/>
+          </a:bodyPr>
+          <a:lstStyle/>
+          <a:p>
+            <a:pPr algn="ctr"/>
+            <a:r>
+              <a:rPr sz="1100" b="1">
+                <a:solidFill>
+                  <a:srgbClr val="2563EB"/>
+                </a:solidFill>
+                <a:latin typeface="Noto Sans CJK KR"/>
+              </a:rPr>
+              <a:t>key 생성</a:t>
+            </a:r>
+          </a:p>
+        </p:txBody>
+      </p:sp>
+      <p:sp>
+        <p:nvSpPr>
+          <p:cNvPr id="30" name="TextBox 29"/>
+          <p:cNvSpPr txBox="1"/>
+          <p:nvPr/>
+        </p:nvSpPr>
+        <p:spPr>
+          <a:xfrm>
+            <a:off x="1143000" y="5422392"/>
+            <a:ext cx="1737360" cy="237744"/>
+          </a:xfrm>
+          <a:prstGeom prst="rect">
+            <a:avLst/>
+          </a:prstGeom>
+          <a:noFill/>
+        </p:spPr>
+        <p:txBody>
+          <a:bodyPr wrap="square">
+            <a:normAutofit/>
+          </a:bodyPr>
+          <a:lstStyle/>
+          <a:p>
+            <a:pPr algn="ctr"/>
+            <a:r>
+              <a:rPr sz="819" b="0">
+                <a:solidFill>
+                  <a:srgbClr val="1F2937"/>
+                </a:solidFill>
+                <a:latin typeface="Noto Sans CJK KR"/>
+              </a:rPr>
+              <a:t>getKey(main, sub)
+→ "main&gt;sub"</a:t>
+            </a:r>
+          </a:p>
+        </p:txBody>
+      </p:sp>
+      <p:cxnSp>
+        <p:nvCxnSpPr>
+          <p:cNvPr id="31" name="Connector 30"/>
+          <p:cNvCxnSpPr/>
+          <p:nvPr/>
+        </p:nvCxnSpPr>
+        <p:spPr>
+          <a:xfrm>
+            <a:off x="3063240" y="5385816"/>
+            <a:ext cx="457200" cy="0"/>
+          </a:xfrm>
+          <a:prstGeom prst="line">
+            <a:avLst/>
+          </a:prstGeom>
+          <a:ln w="19050">
+            <a:solidFill>
+              <a:srgbClr val="CBD5E1"/>
+            </a:solidFill>
+          </a:ln>
+        </p:spPr>
+        <p:style>
+          <a:lnRef idx="2">
+            <a:schemeClr val="accent1"/>
+          </a:lnRef>
+          <a:fillRef idx="0">
+            <a:schemeClr val="accent1"/>
+          </a:fillRef>
+          <a:effectRef idx="1">
+            <a:schemeClr val="accent1"/>
+          </a:effectRef>
+          <a:fontRef idx="minor">
+            <a:schemeClr val="tx1"/>
+          </a:fontRef>
+        </p:style>
+      </p:cxnSp>
+      <p:sp>
+        <p:nvSpPr>
+          <p:cNvPr id="32" name="Rounded Rectangle 31"/>
+          <p:cNvSpPr/>
+          <p:nvPr/>
+        </p:nvSpPr>
+        <p:spPr>
+          <a:xfrm>
+            <a:off x="3611880" y="5074920"/>
+            <a:ext cx="1920240" cy="621792"/>
+          </a:xfrm>
+          <a:prstGeom prst="roundRect">
+            <a:avLst/>
+          </a:prstGeom>
+          <a:solidFill>
+            <a:srgbClr val="EDE9FE"/>
+          </a:solidFill>
+          <a:ln w="13335">
+            <a:solidFill>
+              <a:srgbClr val="7C3AED"/>
+            </a:solidFill>
+          </a:ln>
+        </p:spPr>
+        <p:style>
+          <a:lnRef idx="1">
+            <a:schemeClr val="accent1"/>
+          </a:lnRef>
+          <a:fillRef idx="3">
+            <a:schemeClr val="accent1"/>
+          </a:fillRef>
+          <a:effectRef idx="2">
+            <a:schemeClr val="accent1"/>
+          </a:effectRef>
+          <a:fontRef idx="minor">
+            <a:schemeClr val="lt1"/>
+          </a:fontRef>
+        </p:style>
+        <p:txBody>
+          <a:bodyPr rtlCol="0" anchor="ctr"/>
+          <a:lstStyle/>
+          <a:p>
+            <a:pPr algn="ctr"/>
+          </a:p>
+        </p:txBody>
+      </p:sp>
+      <p:sp>
+        <p:nvSpPr>
+          <p:cNvPr id="33" name="TextBox 32"/>
+          <p:cNvSpPr txBox="1"/>
+          <p:nvPr/>
+        </p:nvSpPr>
+        <p:spPr>
+          <a:xfrm>
+            <a:off x="3685032" y="5138928"/>
+            <a:ext cx="1773936" cy="237744"/>
+          </a:xfrm>
+          <a:prstGeom prst="rect">
+            <a:avLst/>
+          </a:prstGeom>
+          <a:noFill/>
+        </p:spPr>
+        <p:txBody>
+          <a:bodyPr wrap="square">
+            <a:normAutofit/>
+          </a:bodyPr>
+          <a:lstStyle/>
+          <a:p>
+            <a:pPr algn="ctr"/>
+            <a:r>
+              <a:rPr sz="1100" b="1">
+                <a:solidFill>
+                  <a:srgbClr val="7C3AED"/>
+                </a:solidFill>
+                <a:latin typeface="Noto Sans CJK KR"/>
+              </a:rPr>
+              <a:t>수동 토글</a:t>
+            </a:r>
+          </a:p>
+        </p:txBody>
+      </p:sp>
+      <p:sp>
+        <p:nvSpPr>
+          <p:cNvPr id="34" name="TextBox 33"/>
+          <p:cNvSpPr txBox="1"/>
+          <p:nvPr/>
+        </p:nvSpPr>
+        <p:spPr>
+          <a:xfrm>
+            <a:off x="3703320" y="5422392"/>
+            <a:ext cx="1737360" cy="237744"/>
+          </a:xfrm>
+          <a:prstGeom prst="rect">
+            <a:avLst/>
+          </a:prstGeom>
+          <a:noFill/>
+        </p:spPr>
+        <p:txBody>
+          <a:bodyPr wrap="square">
+            <a:normAutofit/>
+          </a:bodyPr>
+          <a:lstStyle/>
+          <a:p>
+            <a:pPr algn="ctr"/>
+            <a:r>
+              <a:rPr sz="819" b="0">
+                <a:solidFill>
+                  <a:srgbClr val="1F2937"/>
+                </a:solidFill>
+                <a:latin typeface="Noto Sans CJK KR"/>
+              </a:rPr>
+              <a:t>handleToggle(key)
+prev[key] 반전</a:t>
+            </a:r>
+          </a:p>
+        </p:txBody>
+      </p:sp>
+      <p:cxnSp>
+        <p:nvCxnSpPr>
+          <p:cNvPr id="35" name="Connector 34"/>
+          <p:cNvCxnSpPr/>
+          <p:nvPr/>
+        </p:nvCxnSpPr>
+        <p:spPr>
+          <a:xfrm>
+            <a:off x="5623560" y="5385816"/>
+            <a:ext cx="457200" cy="0"/>
+          </a:xfrm>
+          <a:prstGeom prst="line">
+            <a:avLst/>
+          </a:prstGeom>
+          <a:ln w="19050">
+            <a:solidFill>
+              <a:srgbClr val="CBD5E1"/>
+            </a:solidFill>
+          </a:ln>
+        </p:spPr>
+        <p:style>
+          <a:lnRef idx="2">
+            <a:schemeClr val="accent1"/>
+          </a:lnRef>
+          <a:fillRef idx="0">
+            <a:schemeClr val="accent1"/>
+          </a:fillRef>
+          <a:effectRef idx="1">
+            <a:schemeClr val="accent1"/>
+          </a:effectRef>
+          <a:fontRef idx="minor">
+            <a:schemeClr val="tx1"/>
+          </a:fontRef>
+        </p:style>
+      </p:cxnSp>
+      <p:sp>
+        <p:nvSpPr>
+          <p:cNvPr id="36" name="Rounded Rectangle 35"/>
+          <p:cNvSpPr/>
+          <p:nvPr/>
+        </p:nvSpPr>
+        <p:spPr>
+          <a:xfrm>
+            <a:off x="6172200" y="5074920"/>
+            <a:ext cx="1920240" cy="621792"/>
+          </a:xfrm>
+          <a:prstGeom prst="roundRect">
+            <a:avLst/>
+          </a:prstGeom>
+          <a:solidFill>
+            <a:srgbClr val="DCFCE7"/>
+          </a:solidFill>
+          <a:ln w="13335">
+            <a:solidFill>
+              <a:srgbClr val="16A34A"/>
+            </a:solidFill>
+          </a:ln>
+        </p:spPr>
+        <p:style>
+          <a:lnRef idx="1">
+            <a:schemeClr val="accent1"/>
+          </a:lnRef>
+          <a:fillRef idx="3">
+            <a:schemeClr val="accent1"/>
+          </a:fillRef>
+          <a:effectRef idx="2">
+            <a:schemeClr val="accent1"/>
+          </a:effectRef>
+          <a:fontRef idx="minor">
+            <a:schemeClr val="lt1"/>
+          </a:fontRef>
+        </p:style>
+        <p:txBody>
+          <a:bodyPr rtlCol="0" anchor="ctr"/>
+          <a:lstStyle/>
+          <a:p>
+            <a:pPr algn="ctr"/>
+          </a:p>
+        </p:txBody>
+      </p:sp>
+      <p:sp>
+        <p:nvSpPr>
+          <p:cNvPr id="37" name="TextBox 36"/>
+          <p:cNvSpPr txBox="1"/>
+          <p:nvPr/>
+        </p:nvSpPr>
+        <p:spPr>
+          <a:xfrm>
+            <a:off x="6245352" y="5138928"/>
+            <a:ext cx="1773936" cy="237744"/>
+          </a:xfrm>
+          <a:prstGeom prst="rect">
+            <a:avLst/>
+          </a:prstGeom>
+          <a:noFill/>
+        </p:spPr>
+        <p:txBody>
+          <a:bodyPr wrap="square">
+            <a:normAutofit/>
+          </a:bodyPr>
+          <a:lstStyle/>
+          <a:p>
+            <a:pPr algn="ctr"/>
+            <a:r>
+              <a:rPr sz="1100" b="1">
+                <a:solidFill>
+                  <a:srgbClr val="16A34A"/>
+                </a:solidFill>
+                <a:latin typeface="Noto Sans CJK KR"/>
+              </a:rPr>
+              <a:t>검색 자동 열림</a:t>
+            </a:r>
+          </a:p>
+        </p:txBody>
+      </p:sp>
+      <p:sp>
+        <p:nvSpPr>
+          <p:cNvPr id="38" name="TextBox 37"/>
+          <p:cNvSpPr txBox="1"/>
+          <p:nvPr/>
+        </p:nvSpPr>
+        <p:spPr>
+          <a:xfrm>
+            <a:off x="6263640" y="5422392"/>
+            <a:ext cx="1737360" cy="237744"/>
+          </a:xfrm>
+          <a:prstGeom prst="rect">
+            <a:avLst/>
+          </a:prstGeom>
+          <a:noFill/>
+        </p:spPr>
+        <p:txBody>
+          <a:bodyPr wrap="square">
+            <a:normAutofit/>
+          </a:bodyPr>
+          <a:lstStyle/>
+          <a:p>
+            <a:pPr algn="ctr"/>
+            <a:r>
+              <a:rPr sz="819" b="0">
+                <a:solidFill>
+                  <a:srgbClr val="1F2937"/>
+                </a:solidFill>
+                <a:latin typeface="Noto Sans CJK KR"/>
+              </a:rPr>
+              <a:t>markPath(path)
+경로 key=true</a:t>
+            </a:r>
+          </a:p>
+        </p:txBody>
+      </p:sp>
+      <p:cxnSp>
+        <p:nvCxnSpPr>
+          <p:cNvPr id="39" name="Connector 38"/>
+          <p:cNvCxnSpPr/>
+          <p:nvPr/>
+        </p:nvCxnSpPr>
+        <p:spPr>
+          <a:xfrm>
+            <a:off x="8183879" y="5385816"/>
+            <a:ext cx="457201" cy="0"/>
+          </a:xfrm>
+          <a:prstGeom prst="line">
+            <a:avLst/>
+          </a:prstGeom>
+          <a:ln w="19050">
+            <a:solidFill>
+              <a:srgbClr val="CBD5E1"/>
+            </a:solidFill>
+          </a:ln>
+        </p:spPr>
+        <p:style>
+          <a:lnRef idx="2">
+            <a:schemeClr val="accent1"/>
+          </a:lnRef>
+          <a:fillRef idx="0">
+            <a:schemeClr val="accent1"/>
+          </a:fillRef>
+          <a:effectRef idx="1">
+            <a:schemeClr val="accent1"/>
+          </a:effectRef>
+          <a:fontRef idx="minor">
+            <a:schemeClr val="tx1"/>
+          </a:fontRef>
+        </p:style>
+      </p:cxnSp>
+      <p:sp>
+        <p:nvSpPr>
+          <p:cNvPr id="40" name="Rounded Rectangle 39"/>
+          <p:cNvSpPr/>
+          <p:nvPr/>
+        </p:nvSpPr>
+        <p:spPr>
+          <a:xfrm>
+            <a:off x="8732520" y="5074920"/>
+            <a:ext cx="2148840" cy="621792"/>
+          </a:xfrm>
+          <a:prstGeom prst="roundRect">
+            <a:avLst/>
+          </a:prstGeom>
+          <a:solidFill>
+            <a:srgbClr val="FEF3C7"/>
+          </a:solidFill>
+          <a:ln w="13335">
+            <a:solidFill>
+              <a:srgbClr val="D97706"/>
+            </a:solidFill>
+          </a:ln>
+        </p:spPr>
+        <p:style>
+          <a:lnRef idx="1">
+            <a:schemeClr val="accent1"/>
+          </a:lnRef>
+          <a:fillRef idx="3">
+            <a:schemeClr val="accent1"/>
+          </a:fillRef>
+          <a:effectRef idx="2">
+            <a:schemeClr val="accent1"/>
+          </a:effectRef>
+          <a:fontRef idx="minor">
+            <a:schemeClr val="lt1"/>
+          </a:fontRef>
+        </p:style>
+        <p:txBody>
+          <a:bodyPr rtlCol="0" anchor="ctr"/>
+          <a:lstStyle/>
+          <a:p>
+            <a:pPr algn="ctr"/>
+          </a:p>
+        </p:txBody>
+      </p:sp>
+      <p:sp>
+        <p:nvSpPr>
+          <p:cNvPr id="41" name="TextBox 40"/>
+          <p:cNvSpPr txBox="1"/>
+          <p:nvPr/>
+        </p:nvSpPr>
+        <p:spPr>
+          <a:xfrm>
+            <a:off x="8805672" y="5138928"/>
+            <a:ext cx="2002536" cy="237744"/>
+          </a:xfrm>
+          <a:prstGeom prst="rect">
+            <a:avLst/>
+          </a:prstGeom>
+          <a:noFill/>
+        </p:spPr>
+        <p:txBody>
+          <a:bodyPr wrap="square">
+            <a:normAutofit/>
+          </a:bodyPr>
+          <a:lstStyle/>
+          <a:p>
+            <a:pPr algn="ctr"/>
+            <a:r>
+              <a:rPr sz="1100" b="1">
+                <a:solidFill>
+                  <a:srgbClr val="D97706"/>
+                </a:solidFill>
+                <a:latin typeface="Noto Sans CJK KR"/>
+              </a:rPr>
+              <a:t>렌더 사용</a:t>
+            </a:r>
+          </a:p>
+        </p:txBody>
+      </p:sp>
+      <p:sp>
+        <p:nvSpPr>
+          <p:cNvPr id="42" name="TextBox 41"/>
+          <p:cNvSpPr txBox="1"/>
+          <p:nvPr/>
+        </p:nvSpPr>
+        <p:spPr>
+          <a:xfrm>
+            <a:off x="8823960" y="5422392"/>
+            <a:ext cx="1965960" cy="237744"/>
+          </a:xfrm>
+          <a:prstGeom prst="rect">
+            <a:avLst/>
+          </a:prstGeom>
+          <a:noFill/>
+        </p:spPr>
+        <p:txBody>
+          <a:bodyPr wrap="square">
+            <a:normAutofit/>
+          </a:bodyPr>
+          <a:lstStyle/>
+          <a:p>
+            <a:pPr algn="ctr"/>
+            <a:r>
+              <a:rPr sz="819" b="0">
+                <a:solidFill>
+                  <a:srgbClr val="1F2937"/>
+                </a:solidFill>
+                <a:latin typeface="Noto Sans CJK KR"/>
+              </a:rPr>
+              <a:t>isSearching ||
+!!openMap[key]</a:t>
+            </a:r>
+          </a:p>
+        </p:txBody>
+      </p:sp>
     </p:spTree>
   </p:cSld>
   <p:clrMapOvr>
@@ -16054,6 +16679,289 @@
                 <a:latin typeface="Noto Sans CJK KR"/>
               </a:rPr>
               <a:t>발표 포인트: 면접 질문 대비: 검색 담당은 filteredTree, 자동 펼침 담당은 useEffect라고 분리해서 설명</a:t>
+            </a:r>
+          </a:p>
+        </p:txBody>
+      </p:sp>
+      <p:sp>
+        <p:nvSpPr>
+          <p:cNvPr id="47" name="Rounded Rectangle 46"/>
+          <p:cNvSpPr/>
+          <p:nvPr/>
+        </p:nvSpPr>
+        <p:spPr>
+          <a:xfrm>
+            <a:off x="822960" y="5605272"/>
+            <a:ext cx="2331720" cy="384048"/>
+          </a:xfrm>
+          <a:prstGeom prst="roundRect">
+            <a:avLst/>
+          </a:prstGeom>
+          <a:solidFill>
+            <a:srgbClr val="DBEAFE"/>
+          </a:solidFill>
+          <a:ln w="13335">
+            <a:solidFill>
+              <a:srgbClr val="2563EB"/>
+            </a:solidFill>
+          </a:ln>
+        </p:spPr>
+        <p:style>
+          <a:lnRef idx="1">
+            <a:schemeClr val="accent1"/>
+          </a:lnRef>
+          <a:fillRef idx="3">
+            <a:schemeClr val="accent1"/>
+          </a:fillRef>
+          <a:effectRef idx="2">
+            <a:schemeClr val="accent1"/>
+          </a:effectRef>
+          <a:fontRef idx="minor">
+            <a:schemeClr val="lt1"/>
+          </a:fontRef>
+        </p:style>
+        <p:txBody>
+          <a:bodyPr rtlCol="0" anchor="ctr"/>
+          <a:lstStyle/>
+          <a:p>
+            <a:pPr algn="ctr"/>
+          </a:p>
+        </p:txBody>
+      </p:sp>
+      <p:sp>
+        <p:nvSpPr>
+          <p:cNvPr id="48" name="TextBox 47"/>
+          <p:cNvSpPr txBox="1"/>
+          <p:nvPr/>
+        </p:nvSpPr>
+        <p:spPr>
+          <a:xfrm>
+            <a:off x="896112" y="5669280"/>
+            <a:ext cx="2185415" cy="237744"/>
+          </a:xfrm>
+          <a:prstGeom prst="rect">
+            <a:avLst/>
+          </a:prstGeom>
+          <a:noFill/>
+        </p:spPr>
+        <p:txBody>
+          <a:bodyPr wrap="square">
+            <a:normAutofit/>
+          </a:bodyPr>
+          <a:lstStyle/>
+          <a:p>
+            <a:pPr algn="ctr"/>
+            <a:r>
+              <a:rPr sz="900" b="1">
+                <a:solidFill>
+                  <a:srgbClr val="2563EB"/>
+                </a:solidFill>
+                <a:latin typeface="Noto Sans CJK KR"/>
+              </a:rPr>
+              <a:t>openMap 결과 예시</a:t>
+            </a:r>
+          </a:p>
+        </p:txBody>
+      </p:sp>
+      <p:sp>
+        <p:nvSpPr>
+          <p:cNvPr id="49" name="Rounded Rectangle 48"/>
+          <p:cNvSpPr/>
+          <p:nvPr/>
+        </p:nvSpPr>
+        <p:spPr>
+          <a:xfrm>
+            <a:off x="3246120" y="5650992"/>
+            <a:ext cx="1828800" cy="292608"/>
+          </a:xfrm>
+          <a:prstGeom prst="roundRect">
+            <a:avLst/>
+          </a:prstGeom>
+          <a:solidFill>
+            <a:srgbClr val="DCFCE7"/>
+          </a:solidFill>
+          <a:ln>
+            <a:solidFill>
+              <a:srgbClr val="DCFCE7"/>
+            </a:solidFill>
+          </a:ln>
+        </p:spPr>
+        <p:style>
+          <a:lnRef idx="1">
+            <a:schemeClr val="accent1"/>
+          </a:lnRef>
+          <a:fillRef idx="3">
+            <a:schemeClr val="accent1"/>
+          </a:fillRef>
+          <a:effectRef idx="2">
+            <a:schemeClr val="accent1"/>
+          </a:effectRef>
+          <a:fontRef idx="minor">
+            <a:schemeClr val="lt1"/>
+          </a:fontRef>
+        </p:style>
+        <p:txBody>
+          <a:bodyPr rtlCol="0" anchor="ctr" wrap="square">
+            <a:normAutofit/>
+          </a:bodyPr>
+          <a:lstStyle/>
+          <a:p>
+            <a:pPr algn="ctr"/>
+            <a:r>
+              <a:rPr sz="800" b="1">
+                <a:solidFill>
+                  <a:srgbClr val="16A34A"/>
+                </a:solidFill>
+                <a:latin typeface="Noto Sans CJK KR"/>
+              </a:rPr>
+              <a:t>"Identity &amp; Crypto": true</a:t>
+            </a:r>
+          </a:p>
+        </p:txBody>
+      </p:sp>
+      <p:sp>
+        <p:nvSpPr>
+          <p:cNvPr id="50" name="Rounded Rectangle 49"/>
+          <p:cNvSpPr/>
+          <p:nvPr/>
+        </p:nvSpPr>
+        <p:spPr>
+          <a:xfrm>
+            <a:off x="5257800" y="5650992"/>
+            <a:ext cx="2103120" cy="292608"/>
+          </a:xfrm>
+          <a:prstGeom prst="roundRect">
+            <a:avLst/>
+          </a:prstGeom>
+          <a:solidFill>
+            <a:srgbClr val="DCFCE7"/>
+          </a:solidFill>
+          <a:ln>
+            <a:solidFill>
+              <a:srgbClr val="DCFCE7"/>
+            </a:solidFill>
+          </a:ln>
+        </p:spPr>
+        <p:style>
+          <a:lnRef idx="1">
+            <a:schemeClr val="accent1"/>
+          </a:lnRef>
+          <a:fillRef idx="3">
+            <a:schemeClr val="accent1"/>
+          </a:fillRef>
+          <a:effectRef idx="2">
+            <a:schemeClr val="accent1"/>
+          </a:effectRef>
+          <a:fontRef idx="minor">
+            <a:schemeClr val="lt1"/>
+          </a:fontRef>
+        </p:style>
+        <p:txBody>
+          <a:bodyPr rtlCol="0" anchor="ctr" wrap="square">
+            <a:normAutofit/>
+          </a:bodyPr>
+          <a:lstStyle/>
+          <a:p>
+            <a:pPr algn="ctr"/>
+            <a:r>
+              <a:rPr sz="800" b="1">
+                <a:solidFill>
+                  <a:srgbClr val="16A34A"/>
+                </a:solidFill>
+                <a:latin typeface="Noto Sans CJK KR"/>
+              </a:rPr>
+              <a:t>"Identity &amp; Crypto&gt;IAM": true</a:t>
+            </a:r>
+          </a:p>
+        </p:txBody>
+      </p:sp>
+      <p:sp>
+        <p:nvSpPr>
+          <p:cNvPr id="51" name="Rounded Rectangle 50"/>
+          <p:cNvSpPr/>
+          <p:nvPr/>
+        </p:nvSpPr>
+        <p:spPr>
+          <a:xfrm>
+            <a:off x="7589520" y="5650992"/>
+            <a:ext cx="1783080" cy="292608"/>
+          </a:xfrm>
+          <a:prstGeom prst="roundRect">
+            <a:avLst/>
+          </a:prstGeom>
+          <a:solidFill>
+            <a:srgbClr val="FFE4E6"/>
+          </a:solidFill>
+          <a:ln>
+            <a:solidFill>
+              <a:srgbClr val="FFE4E6"/>
+            </a:solidFill>
+          </a:ln>
+        </p:spPr>
+        <p:style>
+          <a:lnRef idx="1">
+            <a:schemeClr val="accent1"/>
+          </a:lnRef>
+          <a:fillRef idx="3">
+            <a:schemeClr val="accent1"/>
+          </a:fillRef>
+          <a:effectRef idx="2">
+            <a:schemeClr val="accent1"/>
+          </a:effectRef>
+          <a:fontRef idx="minor">
+            <a:schemeClr val="lt1"/>
+          </a:fontRef>
+        </p:style>
+        <p:txBody>
+          <a:bodyPr rtlCol="0" anchor="ctr" wrap="square">
+            <a:normAutofit/>
+          </a:bodyPr>
+          <a:lstStyle/>
+          <a:p>
+            <a:pPr algn="ctr"/>
+            <a:r>
+              <a:rPr sz="800" b="1">
+                <a:solidFill>
+                  <a:srgbClr val="E11D48"/>
+                </a:solidFill>
+                <a:latin typeface="Noto Sans CJK KR"/>
+              </a:rPr>
+              <a:t>key 없음 = 닫힘(false)</a:t>
+            </a:r>
+          </a:p>
+        </p:txBody>
+      </p:sp>
+      <p:sp>
+        <p:nvSpPr>
+          <p:cNvPr id="52" name="TextBox 51"/>
+          <p:cNvSpPr txBox="1"/>
+          <p:nvPr/>
+        </p:nvSpPr>
+        <p:spPr>
+          <a:xfrm>
+            <a:off x="9555480" y="5596128"/>
+            <a:ext cx="1691640" cy="420624"/>
+          </a:xfrm>
+          <a:prstGeom prst="rect">
+            <a:avLst/>
+          </a:prstGeom>
+          <a:noFill/>
+        </p:spPr>
+        <p:txBody>
+          <a:bodyPr wrap="square">
+            <a:normAutofit/>
+          </a:bodyPr>
+          <a:lstStyle/>
+          <a:p>
+            <a:pPr algn="ctr"/>
+            <a:r>
+              <a:rPr sz="830" b="1">
+                <a:solidFill>
+                  <a:srgbClr val="E11D48"/>
+                </a:solidFill>
+                <a:latin typeface="Noto Sans CJK KR"/>
+              </a:rPr>
+              <a:t>검색어가 비면 setOpenMap({})로 자동 펼침 상태를 초기화</a:t>
             </a:r>
           </a:p>
         </p:txBody>

</xml_diff>